<commit_message>
Update PowerPoint for song #62 in FUBC - Українські
</commit_message>
<xml_diff>
--- a/fubc-ua/62-О Боже, Ти бачиш мене (Пісні Спасенних №57).pptx
+++ b/fubc-ua/62-О Боже, Ти бачиш мене (Пісні Спасенних №57).pptx
@@ -597,7 +597,7 @@
           <a:p>
             <a:r>
               <a:rPr lang="en-US" dirty="0"/>
-              <a:t>1 · 1/1</a:t>
+              <a:t>1 · 1/1 · ||:3-4:||</a:t>
             </a:r>
             <a:endParaRPr lang="en-US" dirty="0"/>
           </a:p>
@@ -685,7 +685,7 @@
           <a:p>
             <a:r>
               <a:rPr lang="en-US" dirty="0"/>
-              <a:t>2 · 1/1</a:t>
+              <a:t>2 · 1/1 · ||:3-4:||</a:t>
             </a:r>
             <a:endParaRPr lang="en-US" dirty="0"/>
           </a:p>
@@ -773,7 +773,7 @@
           <a:p>
             <a:r>
               <a:rPr lang="en-US" dirty="0"/>
-              <a:t>3 · 1/1</a:t>
+              <a:t>3 · 1/1 · ||:3-4:||</a:t>
             </a:r>
             <a:endParaRPr lang="en-US" dirty="0"/>
           </a:p>
@@ -861,7 +861,7 @@
           <a:p>
             <a:r>
               <a:rPr lang="en-US" dirty="0"/>
-              <a:t>4 · 1/1</a:t>
+              <a:t>4 · 1/1 · ||:3-4:||</a:t>
             </a:r>
             <a:endParaRPr lang="en-US" dirty="0"/>
           </a:p>
@@ -949,7 +949,7 @@
           <a:p>
             <a:r>
               <a:rPr lang="en-US" dirty="0"/>
-              <a:t>5 · 1/1</a:t>
+              <a:t>5 · 1/1 · ||:3-4:||</a:t>
             </a:r>
             <a:endParaRPr lang="en-US" dirty="0"/>
           </a:p>
@@ -1037,7 +1037,7 @@
           <a:p>
             <a:r>
               <a:rPr lang="en-US" dirty="0"/>
-              <a:t>6 · 1/1</a:t>
+              <a:t>6 · 1/1 · ||:3-4:||</a:t>
             </a:r>
             <a:endParaRPr lang="en-US" dirty="0"/>
           </a:p>
@@ -1608,6 +1608,9 @@
           <a:lstStyle/>
           <a:p>
             <a:pPr algn="ctr" indent="0" marL="0">
+              <a:lnSpc>
+                <a:spcPts val="6200"/>
+              </a:lnSpc>
               <a:buNone/>
             </a:pPr>
             <a:r>
@@ -1625,6 +1628,9 @@
           </a:p>
           <a:p>
             <a:pPr algn="ctr" indent="0" marL="0">
+              <a:lnSpc>
+                <a:spcPts val="6200"/>
+              </a:lnSpc>
               <a:buNone/>
             </a:pPr>
             <a:r>
@@ -1642,6 +1648,9 @@
           </a:p>
           <a:p>
             <a:pPr algn="ctr" indent="0" marL="0">
+              <a:lnSpc>
+                <a:spcPts val="6200"/>
+              </a:lnSpc>
               <a:buNone/>
             </a:pPr>
             <a:r>
@@ -1653,12 +1662,15 @@
                 <a:ea typeface="Arial" pitchFamily="34" charset="-122"/>
                 <a:cs typeface="Arial" pitchFamily="34" charset="-120"/>
               </a:rPr>
-              <a:t>||: Зміцни, Боже, серце моє,</a:t>
+              <a:t>Зміцни, Боже, серце моє,</a:t>
             </a:r>
             <a:endParaRPr lang="en-US" sz="5200" dirty="0"/>
           </a:p>
           <a:p>
             <a:pPr algn="ctr" indent="0" marL="0">
+              <a:lnSpc>
+                <a:spcPts val="6200"/>
+              </a:lnSpc>
               <a:buNone/>
             </a:pPr>
             <a:r>
@@ -1670,9 +1682,94 @@
                 <a:ea typeface="Arial" pitchFamily="34" charset="-122"/>
                 <a:cs typeface="Arial" pitchFamily="34" charset="-120"/>
               </a:rPr>
-              <a:t>навчи, як служити Тобі! :||</a:t>
+              <a:t>навчи, як служити Тобі!</a:t>
             </a:r>
             <a:endParaRPr lang="en-US" sz="5200" dirty="0"/>
+          </a:p>
+        </p:txBody>
+      </p:sp>
+      <p:sp>
+        <p:nvSpPr>
+          <p:cNvPr id="3" name="Shape 1"/>
+          <p:cNvSpPr/>
+          <p:nvPr/>
+        </p:nvSpPr>
+        <p:spPr>
+          <a:xfrm>
+            <a:off x="1727860" y="3547872"/>
+            <a:ext cx="0" cy="1386840"/>
+          </a:xfrm>
+          <a:prstGeom prst="line">
+            <a:avLst/>
+          </a:prstGeom>
+          <a:noFill/>
+          <a:ln w="25400">
+            <a:solidFill>
+              <a:srgbClr val="8A8A8A"/>
+            </a:solidFill>
+            <a:prstDash val="solid"/>
+          </a:ln>
+        </p:spPr>
+      </p:sp>
+      <p:sp>
+        <p:nvSpPr>
+          <p:cNvPr id="4" name="Shape 2"/>
+          <p:cNvSpPr/>
+          <p:nvPr/>
+        </p:nvSpPr>
+        <p:spPr>
+          <a:xfrm>
+            <a:off x="10470236" y="3547872"/>
+            <a:ext cx="0" cy="1386840"/>
+          </a:xfrm>
+          <a:prstGeom prst="line">
+            <a:avLst/>
+          </a:prstGeom>
+          <a:noFill/>
+          <a:ln w="25400">
+            <a:solidFill>
+              <a:srgbClr val="8A8A8A"/>
+            </a:solidFill>
+            <a:prstDash val="solid"/>
+          </a:ln>
+        </p:spPr>
+      </p:sp>
+      <p:sp>
+        <p:nvSpPr>
+          <p:cNvPr id="5" name="Text 3"/>
+          <p:cNvSpPr txBox="1"/>
+          <p:nvPr/>
+        </p:nvSpPr>
+        <p:spPr>
+          <a:xfrm>
+            <a:off x="10569296" y="3921252"/>
+            <a:ext cx="1097280" cy="640080"/>
+          </a:xfrm>
+          <a:prstGeom prst="rect">
+            <a:avLst/>
+          </a:prstGeom>
+          <a:noFill/>
+          <a:ln/>
+        </p:spPr>
+        <p:txBody>
+          <a:bodyPr wrap="square" lIns="0" tIns="0" rIns="0" bIns="0" rtlCol="0" anchor="ctr"/>
+          <a:lstStyle/>
+          <a:p>
+            <a:pPr algn="l" indent="0" marL="0">
+              <a:buNone/>
+            </a:pPr>
+            <a:r>
+              <a:rPr lang="en-US" sz="3600" b="1" dirty="0">
+                <a:solidFill>
+                  <a:srgbClr val="BBBBBB"/>
+                </a:solidFill>
+                <a:latin typeface="Arial" pitchFamily="34" charset="0"/>
+                <a:ea typeface="Arial" pitchFamily="34" charset="-122"/>
+                <a:cs typeface="Arial" pitchFamily="34" charset="-120"/>
+              </a:rPr>
+              <a:t>×2</a:t>
+            </a:r>
+            <a:endParaRPr lang="en-US" sz="3600" dirty="0"/>
           </a:p>
         </p:txBody>
       </p:sp>
@@ -1730,6 +1827,9 @@
           <a:lstStyle/>
           <a:p>
             <a:pPr algn="ctr" indent="0" marL="0">
+              <a:lnSpc>
+                <a:spcPts val="6200"/>
+              </a:lnSpc>
               <a:buNone/>
             </a:pPr>
             <a:r>
@@ -1747,6 +1847,9 @@
           </a:p>
           <a:p>
             <a:pPr algn="ctr" indent="0" marL="0">
+              <a:lnSpc>
+                <a:spcPts val="6200"/>
+              </a:lnSpc>
               <a:buNone/>
             </a:pPr>
             <a:r>
@@ -1764,6 +1867,9 @@
           </a:p>
           <a:p>
             <a:pPr algn="ctr" indent="0" marL="0">
+              <a:lnSpc>
+                <a:spcPts val="6200"/>
+              </a:lnSpc>
               <a:buNone/>
             </a:pPr>
             <a:r>
@@ -1775,12 +1881,15 @@
                 <a:ea typeface="Arial" pitchFamily="34" charset="-122"/>
                 <a:cs typeface="Arial" pitchFamily="34" charset="-120"/>
               </a:rPr>
-              <a:t>||: О Боже, дай сили мені</a:t>
+              <a:t>О Боже, дай сили мені</a:t>
             </a:r>
             <a:endParaRPr lang="en-US" sz="5200" dirty="0"/>
           </a:p>
           <a:p>
             <a:pPr algn="ctr" indent="0" marL="0">
+              <a:lnSpc>
+                <a:spcPts val="6200"/>
+              </a:lnSpc>
               <a:buNone/>
             </a:pPr>
             <a:r>
@@ -1792,9 +1901,94 @@
                 <a:ea typeface="Arial" pitchFamily="34" charset="-122"/>
                 <a:cs typeface="Arial" pitchFamily="34" charset="-120"/>
               </a:rPr>
-              <a:t>Тебе прославляти завжди. :||</a:t>
+              <a:t>Тебе прославляти завжди.</a:t>
             </a:r>
             <a:endParaRPr lang="en-US" sz="5200" dirty="0"/>
+          </a:p>
+        </p:txBody>
+      </p:sp>
+      <p:sp>
+        <p:nvSpPr>
+          <p:cNvPr id="3" name="Shape 1"/>
+          <p:cNvSpPr/>
+          <p:nvPr/>
+        </p:nvSpPr>
+        <p:spPr>
+          <a:xfrm>
+            <a:off x="1471955" y="3547872"/>
+            <a:ext cx="0" cy="1386840"/>
+          </a:xfrm>
+          <a:prstGeom prst="line">
+            <a:avLst/>
+          </a:prstGeom>
+          <a:noFill/>
+          <a:ln w="25400">
+            <a:solidFill>
+              <a:srgbClr val="8A8A8A"/>
+            </a:solidFill>
+            <a:prstDash val="solid"/>
+          </a:ln>
+        </p:spPr>
+      </p:sp>
+      <p:sp>
+        <p:nvSpPr>
+          <p:cNvPr id="4" name="Shape 2"/>
+          <p:cNvSpPr/>
+          <p:nvPr/>
+        </p:nvSpPr>
+        <p:spPr>
+          <a:xfrm>
+            <a:off x="10726141" y="3547872"/>
+            <a:ext cx="0" cy="1386840"/>
+          </a:xfrm>
+          <a:prstGeom prst="line">
+            <a:avLst/>
+          </a:prstGeom>
+          <a:noFill/>
+          <a:ln w="25400">
+            <a:solidFill>
+              <a:srgbClr val="8A8A8A"/>
+            </a:solidFill>
+            <a:prstDash val="solid"/>
+          </a:ln>
+        </p:spPr>
+      </p:sp>
+      <p:sp>
+        <p:nvSpPr>
+          <p:cNvPr id="5" name="Text 3"/>
+          <p:cNvSpPr txBox="1"/>
+          <p:nvPr/>
+        </p:nvSpPr>
+        <p:spPr>
+          <a:xfrm>
+            <a:off x="10825201" y="3921252"/>
+            <a:ext cx="1097280" cy="640080"/>
+          </a:xfrm>
+          <a:prstGeom prst="rect">
+            <a:avLst/>
+          </a:prstGeom>
+          <a:noFill/>
+          <a:ln/>
+        </p:spPr>
+        <p:txBody>
+          <a:bodyPr wrap="square" lIns="0" tIns="0" rIns="0" bIns="0" rtlCol="0" anchor="ctr"/>
+          <a:lstStyle/>
+          <a:p>
+            <a:pPr algn="l" indent="0" marL="0">
+              <a:buNone/>
+            </a:pPr>
+            <a:r>
+              <a:rPr lang="en-US" sz="3600" b="1" dirty="0">
+                <a:solidFill>
+                  <a:srgbClr val="BBBBBB"/>
+                </a:solidFill>
+                <a:latin typeface="Arial" pitchFamily="34" charset="0"/>
+                <a:ea typeface="Arial" pitchFamily="34" charset="-122"/>
+                <a:cs typeface="Arial" pitchFamily="34" charset="-120"/>
+              </a:rPr>
+              <a:t>×2</a:t>
+            </a:r>
+            <a:endParaRPr lang="en-US" sz="3600" dirty="0"/>
           </a:p>
         </p:txBody>
       </p:sp>
@@ -1852,6 +2046,9 @@
           <a:lstStyle/>
           <a:p>
             <a:pPr algn="ctr" indent="0" marL="0">
+              <a:lnSpc>
+                <a:spcPts val="6200"/>
+              </a:lnSpc>
               <a:buNone/>
             </a:pPr>
             <a:r>
@@ -1869,6 +2066,9 @@
           </a:p>
           <a:p>
             <a:pPr algn="ctr" indent="0" marL="0">
+              <a:lnSpc>
+                <a:spcPts val="6200"/>
+              </a:lnSpc>
               <a:buNone/>
             </a:pPr>
             <a:r>
@@ -1886,6 +2086,9 @@
           </a:p>
           <a:p>
             <a:pPr algn="ctr" indent="0" marL="0">
+              <a:lnSpc>
+                <a:spcPts val="6200"/>
+              </a:lnSpc>
               <a:buNone/>
             </a:pPr>
             <a:r>
@@ -1897,12 +2100,15 @@
                 <a:ea typeface="Arial" pitchFamily="34" charset="-122"/>
                 <a:cs typeface="Arial" pitchFamily="34" charset="-120"/>
               </a:rPr>
-              <a:t>||: і серце моє оживляй,</a:t>
+              <a:t>і серце моє оживляй,</a:t>
             </a:r>
             <a:endParaRPr lang="en-US" sz="5200" dirty="0"/>
           </a:p>
           <a:p>
             <a:pPr algn="ctr" indent="0" marL="0">
+              <a:lnSpc>
+                <a:spcPts val="6200"/>
+              </a:lnSpc>
               <a:buNone/>
             </a:pPr>
             <a:r>
@@ -1914,9 +2120,94 @@
                 <a:ea typeface="Arial" pitchFamily="34" charset="-122"/>
                 <a:cs typeface="Arial" pitchFamily="34" charset="-120"/>
               </a:rPr>
-              <a:t>наповнюй Собою життя. :||</a:t>
+              <a:t>наповнюй Собою життя.</a:t>
             </a:r>
             <a:endParaRPr lang="en-US" sz="5200" dirty="0"/>
+          </a:p>
+        </p:txBody>
+      </p:sp>
+      <p:sp>
+        <p:nvSpPr>
+          <p:cNvPr id="3" name="Shape 1"/>
+          <p:cNvSpPr/>
+          <p:nvPr/>
+        </p:nvSpPr>
+        <p:spPr>
+          <a:xfrm>
+            <a:off x="1839468" y="3547872"/>
+            <a:ext cx="0" cy="1386840"/>
+          </a:xfrm>
+          <a:prstGeom prst="line">
+            <a:avLst/>
+          </a:prstGeom>
+          <a:noFill/>
+          <a:ln w="25400">
+            <a:solidFill>
+              <a:srgbClr val="8A8A8A"/>
+            </a:solidFill>
+            <a:prstDash val="solid"/>
+          </a:ln>
+        </p:spPr>
+      </p:sp>
+      <p:sp>
+        <p:nvSpPr>
+          <p:cNvPr id="4" name="Shape 2"/>
+          <p:cNvSpPr/>
+          <p:nvPr/>
+        </p:nvSpPr>
+        <p:spPr>
+          <a:xfrm>
+            <a:off x="10358628" y="3547872"/>
+            <a:ext cx="0" cy="1386840"/>
+          </a:xfrm>
+          <a:prstGeom prst="line">
+            <a:avLst/>
+          </a:prstGeom>
+          <a:noFill/>
+          <a:ln w="25400">
+            <a:solidFill>
+              <a:srgbClr val="8A8A8A"/>
+            </a:solidFill>
+            <a:prstDash val="solid"/>
+          </a:ln>
+        </p:spPr>
+      </p:sp>
+      <p:sp>
+        <p:nvSpPr>
+          <p:cNvPr id="5" name="Text 3"/>
+          <p:cNvSpPr txBox="1"/>
+          <p:nvPr/>
+        </p:nvSpPr>
+        <p:spPr>
+          <a:xfrm>
+            <a:off x="10457688" y="3921252"/>
+            <a:ext cx="1097280" cy="640080"/>
+          </a:xfrm>
+          <a:prstGeom prst="rect">
+            <a:avLst/>
+          </a:prstGeom>
+          <a:noFill/>
+          <a:ln/>
+        </p:spPr>
+        <p:txBody>
+          <a:bodyPr wrap="square" lIns="0" tIns="0" rIns="0" bIns="0" rtlCol="0" anchor="ctr"/>
+          <a:lstStyle/>
+          <a:p>
+            <a:pPr algn="l" indent="0" marL="0">
+              <a:buNone/>
+            </a:pPr>
+            <a:r>
+              <a:rPr lang="en-US" sz="3600" b="1" dirty="0">
+                <a:solidFill>
+                  <a:srgbClr val="BBBBBB"/>
+                </a:solidFill>
+                <a:latin typeface="Arial" pitchFamily="34" charset="0"/>
+                <a:ea typeface="Arial" pitchFamily="34" charset="-122"/>
+                <a:cs typeface="Arial" pitchFamily="34" charset="-120"/>
+              </a:rPr>
+              <a:t>×2</a:t>
+            </a:r>
+            <a:endParaRPr lang="en-US" sz="3600" dirty="0"/>
           </a:p>
         </p:txBody>
       </p:sp>
@@ -1974,6 +2265,9 @@
           <a:lstStyle/>
           <a:p>
             <a:pPr algn="ctr" indent="0" marL="0">
+              <a:lnSpc>
+                <a:spcPts val="6200"/>
+              </a:lnSpc>
               <a:buNone/>
             </a:pPr>
             <a:r>
@@ -1991,6 +2285,9 @@
           </a:p>
           <a:p>
             <a:pPr algn="ctr" indent="0" marL="0">
+              <a:lnSpc>
+                <a:spcPts val="6200"/>
+              </a:lnSpc>
               <a:buNone/>
             </a:pPr>
             <a:r>
@@ -2008,6 +2305,9 @@
           </a:p>
           <a:p>
             <a:pPr algn="ctr" indent="0" marL="0">
+              <a:lnSpc>
+                <a:spcPts val="6200"/>
+              </a:lnSpc>
               <a:buNone/>
             </a:pPr>
             <a:r>
@@ -2019,12 +2319,15 @@
                 <a:ea typeface="Arial" pitchFamily="34" charset="-122"/>
                 <a:cs typeface="Arial" pitchFamily="34" charset="-120"/>
               </a:rPr>
-              <a:t>||: був вірний завітам святим,</a:t>
+              <a:t>був вірний завітам святим,</a:t>
             </a:r>
             <a:endParaRPr lang="en-US" sz="5200" dirty="0"/>
           </a:p>
           <a:p>
             <a:pPr algn="ctr" indent="0" marL="0">
+              <a:lnSpc>
+                <a:spcPts val="6200"/>
+              </a:lnSpc>
               <a:buNone/>
             </a:pPr>
             <a:r>
@@ -2036,9 +2339,94 @@
                 <a:ea typeface="Arial" pitchFamily="34" charset="-122"/>
                 <a:cs typeface="Arial" pitchFamily="34" charset="-120"/>
               </a:rPr>
-              <a:t>на ниві Твоїй працював. :||</a:t>
+              <a:t>на ниві Твоїй працював.</a:t>
             </a:r>
             <a:endParaRPr lang="en-US" sz="5200" dirty="0"/>
+          </a:p>
+        </p:txBody>
+      </p:sp>
+      <p:sp>
+        <p:nvSpPr>
+          <p:cNvPr id="3" name="Shape 1"/>
+          <p:cNvSpPr/>
+          <p:nvPr/>
+        </p:nvSpPr>
+        <p:spPr>
+          <a:xfrm>
+            <a:off x="1387094" y="3547872"/>
+            <a:ext cx="0" cy="1386840"/>
+          </a:xfrm>
+          <a:prstGeom prst="line">
+            <a:avLst/>
+          </a:prstGeom>
+          <a:noFill/>
+          <a:ln w="25400">
+            <a:solidFill>
+              <a:srgbClr val="8A8A8A"/>
+            </a:solidFill>
+            <a:prstDash val="solid"/>
+          </a:ln>
+        </p:spPr>
+      </p:sp>
+      <p:sp>
+        <p:nvSpPr>
+          <p:cNvPr id="4" name="Shape 2"/>
+          <p:cNvSpPr/>
+          <p:nvPr/>
+        </p:nvSpPr>
+        <p:spPr>
+          <a:xfrm>
+            <a:off x="10811002" y="3547872"/>
+            <a:ext cx="0" cy="1386840"/>
+          </a:xfrm>
+          <a:prstGeom prst="line">
+            <a:avLst/>
+          </a:prstGeom>
+          <a:noFill/>
+          <a:ln w="25400">
+            <a:solidFill>
+              <a:srgbClr val="8A8A8A"/>
+            </a:solidFill>
+            <a:prstDash val="solid"/>
+          </a:ln>
+        </p:spPr>
+      </p:sp>
+      <p:sp>
+        <p:nvSpPr>
+          <p:cNvPr id="5" name="Text 3"/>
+          <p:cNvSpPr txBox="1"/>
+          <p:nvPr/>
+        </p:nvSpPr>
+        <p:spPr>
+          <a:xfrm>
+            <a:off x="10910062" y="3921252"/>
+            <a:ext cx="1097280" cy="640080"/>
+          </a:xfrm>
+          <a:prstGeom prst="rect">
+            <a:avLst/>
+          </a:prstGeom>
+          <a:noFill/>
+          <a:ln/>
+        </p:spPr>
+        <p:txBody>
+          <a:bodyPr wrap="square" lIns="0" tIns="0" rIns="0" bIns="0" rtlCol="0" anchor="ctr"/>
+          <a:lstStyle/>
+          <a:p>
+            <a:pPr algn="l" indent="0" marL="0">
+              <a:buNone/>
+            </a:pPr>
+            <a:r>
+              <a:rPr lang="en-US" sz="3600" b="1" dirty="0">
+                <a:solidFill>
+                  <a:srgbClr val="BBBBBB"/>
+                </a:solidFill>
+                <a:latin typeface="Arial" pitchFamily="34" charset="0"/>
+                <a:ea typeface="Arial" pitchFamily="34" charset="-122"/>
+                <a:cs typeface="Arial" pitchFamily="34" charset="-120"/>
+              </a:rPr>
+              <a:t>×2</a:t>
+            </a:r>
+            <a:endParaRPr lang="en-US" sz="3600" dirty="0"/>
           </a:p>
         </p:txBody>
       </p:sp>
@@ -2096,6 +2484,9 @@
           <a:lstStyle/>
           <a:p>
             <a:pPr algn="ctr" indent="0" marL="0">
+              <a:lnSpc>
+                <a:spcPts val="6200"/>
+              </a:lnSpc>
               <a:buNone/>
             </a:pPr>
             <a:r>
@@ -2113,6 +2504,9 @@
           </a:p>
           <a:p>
             <a:pPr algn="ctr" indent="0" marL="0">
+              <a:lnSpc>
+                <a:spcPts val="6200"/>
+              </a:lnSpc>
               <a:buNone/>
             </a:pPr>
             <a:r>
@@ -2130,6 +2524,9 @@
           </a:p>
           <a:p>
             <a:pPr algn="ctr" indent="0" marL="0">
+              <a:lnSpc>
+                <a:spcPts val="6200"/>
+              </a:lnSpc>
               <a:buNone/>
             </a:pPr>
             <a:r>
@@ -2141,12 +2538,15 @@
                 <a:ea typeface="Arial" pitchFamily="34" charset="-122"/>
                 <a:cs typeface="Arial" pitchFamily="34" charset="-120"/>
               </a:rPr>
-              <a:t>||: щоб міг я в святих небесах</a:t>
+              <a:t>щоб міг я в святих небесах</a:t>
             </a:r>
             <a:endParaRPr lang="en-US" sz="5200" dirty="0"/>
           </a:p>
           <a:p>
             <a:pPr algn="ctr" indent="0" marL="0">
+              <a:lnSpc>
+                <a:spcPts val="6200"/>
+              </a:lnSpc>
               <a:buNone/>
             </a:pPr>
             <a:r>
@@ -2158,9 +2558,94 @@
                 <a:ea typeface="Arial" pitchFamily="34" charset="-122"/>
                 <a:cs typeface="Arial" pitchFamily="34" charset="-120"/>
               </a:rPr>
-              <a:t>Тебе прославляти завжди. :||</a:t>
+              <a:t>Тебе прославляти завжди.</a:t>
             </a:r>
             <a:endParaRPr lang="en-US" sz="5200" dirty="0"/>
+          </a:p>
+        </p:txBody>
+      </p:sp>
+      <p:sp>
+        <p:nvSpPr>
+          <p:cNvPr id="3" name="Shape 1"/>
+          <p:cNvSpPr/>
+          <p:nvPr/>
+        </p:nvSpPr>
+        <p:spPr>
+          <a:xfrm>
+            <a:off x="1405915" y="3547872"/>
+            <a:ext cx="0" cy="1386840"/>
+          </a:xfrm>
+          <a:prstGeom prst="line">
+            <a:avLst/>
+          </a:prstGeom>
+          <a:noFill/>
+          <a:ln w="25400">
+            <a:solidFill>
+              <a:srgbClr val="8A8A8A"/>
+            </a:solidFill>
+            <a:prstDash val="solid"/>
+          </a:ln>
+        </p:spPr>
+      </p:sp>
+      <p:sp>
+        <p:nvSpPr>
+          <p:cNvPr id="4" name="Shape 2"/>
+          <p:cNvSpPr/>
+          <p:nvPr/>
+        </p:nvSpPr>
+        <p:spPr>
+          <a:xfrm>
+            <a:off x="10792181" y="3547872"/>
+            <a:ext cx="0" cy="1386840"/>
+          </a:xfrm>
+          <a:prstGeom prst="line">
+            <a:avLst/>
+          </a:prstGeom>
+          <a:noFill/>
+          <a:ln w="25400">
+            <a:solidFill>
+              <a:srgbClr val="8A8A8A"/>
+            </a:solidFill>
+            <a:prstDash val="solid"/>
+          </a:ln>
+        </p:spPr>
+      </p:sp>
+      <p:sp>
+        <p:nvSpPr>
+          <p:cNvPr id="5" name="Text 3"/>
+          <p:cNvSpPr txBox="1"/>
+          <p:nvPr/>
+        </p:nvSpPr>
+        <p:spPr>
+          <a:xfrm>
+            <a:off x="10891241" y="3921252"/>
+            <a:ext cx="1097280" cy="640080"/>
+          </a:xfrm>
+          <a:prstGeom prst="rect">
+            <a:avLst/>
+          </a:prstGeom>
+          <a:noFill/>
+          <a:ln/>
+        </p:spPr>
+        <p:txBody>
+          <a:bodyPr wrap="square" lIns="0" tIns="0" rIns="0" bIns="0" rtlCol="0" anchor="ctr"/>
+          <a:lstStyle/>
+          <a:p>
+            <a:pPr algn="l" indent="0" marL="0">
+              <a:buNone/>
+            </a:pPr>
+            <a:r>
+              <a:rPr lang="en-US" sz="3600" b="1" dirty="0">
+                <a:solidFill>
+                  <a:srgbClr val="BBBBBB"/>
+                </a:solidFill>
+                <a:latin typeface="Arial" pitchFamily="34" charset="0"/>
+                <a:ea typeface="Arial" pitchFamily="34" charset="-122"/>
+                <a:cs typeface="Arial" pitchFamily="34" charset="-120"/>
+              </a:rPr>
+              <a:t>×2</a:t>
+            </a:r>
+            <a:endParaRPr lang="en-US" sz="3600" dirty="0"/>
           </a:p>
         </p:txBody>
       </p:sp>
@@ -2218,10 +2703,13 @@
           <a:lstStyle/>
           <a:p>
             <a:pPr algn="ctr" indent="0" marL="0">
+              <a:lnSpc>
+                <a:spcPts val="6100"/>
+              </a:lnSpc>
               <a:buNone/>
             </a:pPr>
             <a:r>
-              <a:rPr lang="en-US" sz="5200" b="1" dirty="0">
+              <a:rPr lang="en-US" sz="5100" b="1" dirty="0">
                 <a:solidFill>
                   <a:srgbClr val="FFFFFF"/>
                 </a:solidFill>
@@ -2231,14 +2719,17 @@
               </a:rPr>
               <a:t>О Боже, дай сили мені,</a:t>
             </a:r>
-            <a:endParaRPr lang="en-US" sz="5200" dirty="0"/>
+            <a:endParaRPr lang="en-US" sz="5100" dirty="0"/>
           </a:p>
           <a:p>
             <a:pPr algn="ctr" indent="0" marL="0">
+              <a:lnSpc>
+                <a:spcPts val="6100"/>
+              </a:lnSpc>
               <a:buNone/>
             </a:pPr>
             <a:r>
-              <a:rPr lang="en-US" sz="5200" b="1" dirty="0">
+              <a:rPr lang="en-US" sz="5100" b="1" dirty="0">
                 <a:solidFill>
                   <a:srgbClr val="FFFFFF"/>
                 </a:solidFill>
@@ -2248,14 +2739,17 @@
               </a:rPr>
               <a:t>щоб хрест свій смиренно я ніс,</a:t>
             </a:r>
-            <a:endParaRPr lang="en-US" sz="5200" dirty="0"/>
+            <a:endParaRPr lang="en-US" sz="5100" dirty="0"/>
           </a:p>
           <a:p>
             <a:pPr algn="ctr" indent="0" marL="0">
+              <a:lnSpc>
+                <a:spcPts val="6100"/>
+              </a:lnSpc>
               <a:buNone/>
             </a:pPr>
             <a:r>
-              <a:rPr lang="en-US" sz="5200" b="1" dirty="0">
+              <a:rPr lang="en-US" sz="5100" b="1" dirty="0">
                 <a:solidFill>
                   <a:srgbClr val="FFFFFF"/>
                 </a:solidFill>
@@ -2263,16 +2757,19 @@
                 <a:ea typeface="Arial" pitchFamily="34" charset="-122"/>
                 <a:cs typeface="Arial" pitchFamily="34" charset="-120"/>
               </a:rPr>
-              <a:t>||: не впав у земній боротьбі,</a:t>
-            </a:r>
-            <a:endParaRPr lang="en-US" sz="5200" dirty="0"/>
+              <a:t>не впав у земній боротьбі,</a:t>
+            </a:r>
+            <a:endParaRPr lang="en-US" sz="5100" dirty="0"/>
           </a:p>
           <a:p>
             <a:pPr algn="ctr" indent="0" marL="0">
+              <a:lnSpc>
+                <a:spcPts val="6100"/>
+              </a:lnSpc>
               <a:buNone/>
             </a:pPr>
             <a:r>
-              <a:rPr lang="en-US" sz="5200" b="1" dirty="0">
+              <a:rPr lang="en-US" sz="5100" b="1" dirty="0">
                 <a:solidFill>
                   <a:srgbClr val="FFFFFF"/>
                 </a:solidFill>
@@ -2280,15 +2777,100 @@
                 <a:ea typeface="Arial" pitchFamily="34" charset="-122"/>
                 <a:cs typeface="Arial" pitchFamily="34" charset="-120"/>
               </a:rPr>
-              <a:t>рясний плід для Тебе приніс. :||</a:t>
-            </a:r>
-            <a:endParaRPr lang="en-US" sz="5200" dirty="0"/>
-          </a:p>
-        </p:txBody>
-      </p:sp>
-      <p:sp>
-        <p:nvSpPr>
-          <p:cNvPr id="3" name="Text 1"/>
+              <a:t>рясний плід для Тебе приніс.</a:t>
+            </a:r>
+            <a:endParaRPr lang="en-US" sz="5100" dirty="0"/>
+          </a:p>
+        </p:txBody>
+      </p:sp>
+      <p:sp>
+        <p:nvSpPr>
+          <p:cNvPr id="3" name="Shape 1"/>
+          <p:cNvSpPr/>
+          <p:nvPr/>
+        </p:nvSpPr>
+        <p:spPr>
+          <a:xfrm>
+            <a:off x="1148029" y="3545586"/>
+            <a:ext cx="0" cy="1360170"/>
+          </a:xfrm>
+          <a:prstGeom prst="line">
+            <a:avLst/>
+          </a:prstGeom>
+          <a:noFill/>
+          <a:ln w="24912">
+            <a:solidFill>
+              <a:srgbClr val="8A8A8A"/>
+            </a:solidFill>
+            <a:prstDash val="solid"/>
+          </a:ln>
+        </p:spPr>
+      </p:sp>
+      <p:sp>
+        <p:nvSpPr>
+          <p:cNvPr id="4" name="Shape 2"/>
+          <p:cNvSpPr/>
+          <p:nvPr/>
+        </p:nvSpPr>
+        <p:spPr>
+          <a:xfrm>
+            <a:off x="11050067" y="3545586"/>
+            <a:ext cx="0" cy="1360170"/>
+          </a:xfrm>
+          <a:prstGeom prst="line">
+            <a:avLst/>
+          </a:prstGeom>
+          <a:noFill/>
+          <a:ln w="24912">
+            <a:solidFill>
+              <a:srgbClr val="8A8A8A"/>
+            </a:solidFill>
+            <a:prstDash val="solid"/>
+          </a:ln>
+        </p:spPr>
+      </p:sp>
+      <p:sp>
+        <p:nvSpPr>
+          <p:cNvPr id="5" name="Text 3"/>
+          <p:cNvSpPr txBox="1"/>
+          <p:nvPr/>
+        </p:nvSpPr>
+        <p:spPr>
+          <a:xfrm>
+            <a:off x="11147222" y="3905631"/>
+            <a:ext cx="1097280" cy="640080"/>
+          </a:xfrm>
+          <a:prstGeom prst="rect">
+            <a:avLst/>
+          </a:prstGeom>
+          <a:noFill/>
+          <a:ln/>
+        </p:spPr>
+        <p:txBody>
+          <a:bodyPr wrap="square" lIns="0" tIns="0" rIns="0" bIns="0" rtlCol="0" anchor="ctr"/>
+          <a:lstStyle/>
+          <a:p>
+            <a:pPr algn="l" indent="0" marL="0">
+              <a:buNone/>
+            </a:pPr>
+            <a:r>
+              <a:rPr lang="en-US" sz="3600" b="1" dirty="0">
+                <a:solidFill>
+                  <a:srgbClr val="BBBBBB"/>
+                </a:solidFill>
+                <a:latin typeface="Arial" pitchFamily="34" charset="0"/>
+                <a:ea typeface="Arial" pitchFamily="34" charset="-122"/>
+                <a:cs typeface="Arial" pitchFamily="34" charset="-120"/>
+              </a:rPr>
+              <a:t>×2</a:t>
+            </a:r>
+            <a:endParaRPr lang="en-US" sz="3600" dirty="0"/>
+          </a:p>
+        </p:txBody>
+      </p:sp>
+      <p:sp>
+        <p:nvSpPr>
+          <p:cNvPr id="6" name="Text 4"/>
           <p:cNvSpPr txBox="1"/>
           <p:nvPr/>
         </p:nvSpPr>

</xml_diff>